<commit_message>
Color doubled-vowel letter cards: vowels red, consonants green.
</commit_message>
<xml_diff>
--- a/output/svet-moy-zerkalce-letters-colored.pptx
+++ b/output/svet-moy-zerkalce-letters-colored.pptx
@@ -3497,7 +3497,7 @@
             <a:r>
               <a:rPr sz="10410" b="1">
                 <a:solidFill>
-                  <a:srgbClr val="0000FF"/>
+                  <a:srgbClr val="008000"/>
                 </a:solidFill>
                 <a:latin typeface="Arial"/>
               </a:rPr>
@@ -3543,7 +3543,7 @@
             <a:r>
               <a:rPr sz="10410" b="1">
                 <a:solidFill>
-                  <a:srgbClr val="0000FF"/>
+                  <a:srgbClr val="008000"/>
                 </a:solidFill>
                 <a:latin typeface="Arial"/>
               </a:rPr>
@@ -3589,7 +3589,7 @@
             <a:r>
               <a:rPr sz="10410" b="1">
                 <a:solidFill>
-                  <a:srgbClr val="0000FF"/>
+                  <a:srgbClr val="008000"/>
                 </a:solidFill>
                 <a:latin typeface="Arial"/>
               </a:rPr>
@@ -3635,7 +3635,7 @@
             <a:r>
               <a:rPr sz="10410" b="1">
                 <a:solidFill>
-                  <a:srgbClr val="0000FF"/>
+                  <a:srgbClr val="008000"/>
                 </a:solidFill>
                 <a:latin typeface="Arial"/>
               </a:rPr>
@@ -3681,7 +3681,7 @@
             <a:r>
               <a:rPr sz="10410" b="1">
                 <a:solidFill>
-                  <a:srgbClr val="0000FF"/>
+                  <a:srgbClr val="008000"/>
                 </a:solidFill>
                 <a:latin typeface="Arial"/>
               </a:rPr>
@@ -3727,7 +3727,7 @@
             <a:r>
               <a:rPr sz="10410" b="1">
                 <a:solidFill>
-                  <a:srgbClr val="0000FF"/>
+                  <a:srgbClr val="008000"/>
                 </a:solidFill>
                 <a:latin typeface="Arial"/>
               </a:rPr>
@@ -3773,7 +3773,7 @@
             <a:r>
               <a:rPr sz="10410" b="1">
                 <a:solidFill>
-                  <a:srgbClr val="0000FF"/>
+                  <a:srgbClr val="008000"/>
                 </a:solidFill>
                 <a:latin typeface="Arial"/>
               </a:rPr>
@@ -3819,7 +3819,7 @@
             <a:r>
               <a:rPr sz="10410" b="1">
                 <a:solidFill>
-                  <a:srgbClr val="0000FF"/>
+                  <a:srgbClr val="008000"/>
                 </a:solidFill>
                 <a:latin typeface="Arial"/>
               </a:rPr>
@@ -3865,7 +3865,7 @@
             <a:r>
               <a:rPr sz="10410" b="1">
                 <a:solidFill>
-                  <a:srgbClr val="0000FF"/>
+                  <a:srgbClr val="008000"/>
                 </a:solidFill>
                 <a:latin typeface="Arial"/>
               </a:rPr>
@@ -5845,7 +5845,7 @@
             <a:r>
               <a:rPr sz="10410" b="1">
                 <a:solidFill>
-                  <a:srgbClr val="0000FF"/>
+                  <a:srgbClr val="008000"/>
                 </a:solidFill>
                 <a:latin typeface="Arial"/>
               </a:rPr>
@@ -5891,7 +5891,7 @@
             <a:r>
               <a:rPr sz="10410" b="1">
                 <a:solidFill>
-                  <a:srgbClr val="0000FF"/>
+                  <a:srgbClr val="008000"/>
                 </a:solidFill>
                 <a:latin typeface="Arial"/>
               </a:rPr>
@@ -5937,7 +5937,7 @@
             <a:r>
               <a:rPr sz="10410" b="1">
                 <a:solidFill>
-                  <a:srgbClr val="0000FF"/>
+                  <a:srgbClr val="008000"/>
                 </a:solidFill>
                 <a:latin typeface="Arial"/>
               </a:rPr>
@@ -6351,7 +6351,7 @@
             <a:r>
               <a:rPr sz="10410" b="1">
                 <a:solidFill>
-                  <a:srgbClr val="0000FF"/>
+                  <a:srgbClr val="008000"/>
                 </a:solidFill>
                 <a:latin typeface="Arial"/>
               </a:rPr>
@@ -6397,7 +6397,7 @@
             <a:r>
               <a:rPr sz="10410" b="1">
                 <a:solidFill>
-                  <a:srgbClr val="0000FF"/>
+                  <a:srgbClr val="008000"/>
                 </a:solidFill>
                 <a:latin typeface="Arial"/>
               </a:rPr>
@@ -7917,7 +7917,7 @@
             <a:r>
               <a:rPr sz="10410" b="1">
                 <a:solidFill>
-                  <a:srgbClr val="0000FF"/>
+                  <a:srgbClr val="008000"/>
                 </a:solidFill>
                 <a:latin typeface="Arial"/>
               </a:rPr>
@@ -7963,7 +7963,7 @@
             <a:r>
               <a:rPr sz="10410" b="1">
                 <a:solidFill>
-                  <a:srgbClr val="0000FF"/>
+                  <a:srgbClr val="008000"/>
                 </a:solidFill>
                 <a:latin typeface="Arial"/>
               </a:rPr>
@@ -8009,7 +8009,7 @@
             <a:r>
               <a:rPr sz="10410" b="1">
                 <a:solidFill>
-                  <a:srgbClr val="0000FF"/>
+                  <a:srgbClr val="008000"/>
                 </a:solidFill>
                 <a:latin typeface="Arial"/>
               </a:rPr>
@@ -8055,7 +8055,7 @@
             <a:r>
               <a:rPr sz="10410" b="1">
                 <a:solidFill>
-                  <a:srgbClr val="0000FF"/>
+                  <a:srgbClr val="008000"/>
                 </a:solidFill>
                 <a:latin typeface="Arial"/>
               </a:rPr>
@@ -8101,7 +8101,7 @@
             <a:r>
               <a:rPr sz="10410" b="1">
                 <a:solidFill>
-                  <a:srgbClr val="0000FF"/>
+                  <a:srgbClr val="008000"/>
                 </a:solidFill>
                 <a:latin typeface="Arial"/>
               </a:rPr>
@@ -8147,7 +8147,7 @@
             <a:r>
               <a:rPr sz="10410" b="1">
                 <a:solidFill>
-                  <a:srgbClr val="0000FF"/>
+                  <a:srgbClr val="008000"/>
                 </a:solidFill>
                 <a:latin typeface="Arial"/>
               </a:rPr>
@@ -8193,7 +8193,7 @@
             <a:r>
               <a:rPr sz="10410" b="1">
                 <a:solidFill>
-                  <a:srgbClr val="0000FF"/>
+                  <a:srgbClr val="008000"/>
                 </a:solidFill>
                 <a:latin typeface="Arial"/>
               </a:rPr>
@@ -8239,7 +8239,7 @@
             <a:r>
               <a:rPr sz="10410" b="1">
                 <a:solidFill>
-                  <a:srgbClr val="0000FF"/>
+                  <a:srgbClr val="008000"/>
                 </a:solidFill>
                 <a:latin typeface="Arial"/>
               </a:rPr>
@@ -8285,7 +8285,7 @@
             <a:r>
               <a:rPr sz="10410" b="1">
                 <a:solidFill>
-                  <a:srgbClr val="0000FF"/>
+                  <a:srgbClr val="008000"/>
                 </a:solidFill>
                 <a:latin typeface="Arial"/>
               </a:rPr>
@@ -8331,7 +8331,7 @@
             <a:r>
               <a:rPr sz="10410" b="1">
                 <a:solidFill>
-                  <a:srgbClr val="0000FF"/>
+                  <a:srgbClr val="008000"/>
                 </a:solidFill>
                 <a:latin typeface="Arial"/>
               </a:rPr>
@@ -8377,7 +8377,7 @@
             <a:r>
               <a:rPr sz="10410" b="1">
                 <a:solidFill>
-                  <a:srgbClr val="0000FF"/>
+                  <a:srgbClr val="008000"/>
                 </a:solidFill>
                 <a:latin typeface="Arial"/>
               </a:rPr>
@@ -10357,7 +10357,7 @@
             <a:r>
               <a:rPr sz="10410" b="1">
                 <a:solidFill>
-                  <a:srgbClr val="0000FF"/>
+                  <a:srgbClr val="008000"/>
                 </a:solidFill>
                 <a:latin typeface="Arial"/>
               </a:rPr>
@@ -10403,7 +10403,7 @@
             <a:r>
               <a:rPr sz="10410" b="1">
                 <a:solidFill>
-                  <a:srgbClr val="0000FF"/>
+                  <a:srgbClr val="008000"/>
                 </a:solidFill>
                 <a:latin typeface="Arial"/>
               </a:rPr>
@@ -10449,7 +10449,7 @@
             <a:r>
               <a:rPr sz="10410" b="1">
                 <a:solidFill>
-                  <a:srgbClr val="0000FF"/>
+                  <a:srgbClr val="008000"/>
                 </a:solidFill>
                 <a:latin typeface="Arial"/>
               </a:rPr>
@@ -10495,7 +10495,7 @@
             <a:r>
               <a:rPr sz="10410" b="1">
                 <a:solidFill>
-                  <a:srgbClr val="0000FF"/>
+                  <a:srgbClr val="008000"/>
                 </a:solidFill>
                 <a:latin typeface="Arial"/>
               </a:rPr>
@@ -10541,7 +10541,7 @@
             <a:r>
               <a:rPr sz="10410" b="1">
                 <a:solidFill>
-                  <a:srgbClr val="0000FF"/>
+                  <a:srgbClr val="008000"/>
                 </a:solidFill>
                 <a:latin typeface="Arial"/>
               </a:rPr>
@@ -10587,7 +10587,7 @@
             <a:r>
               <a:rPr sz="10410" b="1">
                 <a:solidFill>
-                  <a:srgbClr val="0000FF"/>
+                  <a:srgbClr val="008000"/>
                 </a:solidFill>
                 <a:latin typeface="Arial"/>
               </a:rPr>
@@ -10633,7 +10633,7 @@
             <a:r>
               <a:rPr sz="10410" b="1">
                 <a:solidFill>
-                  <a:srgbClr val="0000FF"/>
+                  <a:srgbClr val="008000"/>
                 </a:solidFill>
                 <a:latin typeface="Arial"/>
               </a:rPr>
@@ -10679,7 +10679,7 @@
             <a:r>
               <a:rPr sz="10410" b="1">
                 <a:solidFill>
-                  <a:srgbClr val="0000FF"/>
+                  <a:srgbClr val="008000"/>
                 </a:solidFill>
                 <a:latin typeface="Arial"/>
               </a:rPr>
@@ -10725,7 +10725,7 @@
             <a:r>
               <a:rPr sz="10410" b="1">
                 <a:solidFill>
-                  <a:srgbClr val="0000FF"/>
+                  <a:srgbClr val="008000"/>
                 </a:solidFill>
                 <a:latin typeface="Arial"/>
               </a:rPr>
@@ -10771,7 +10771,7 @@
             <a:r>
               <a:rPr sz="10410" b="1">
                 <a:solidFill>
-                  <a:srgbClr val="0000FF"/>
+                  <a:srgbClr val="008000"/>
                 </a:solidFill>
                 <a:latin typeface="Arial"/>
               </a:rPr>
@@ -10817,7 +10817,7 @@
             <a:r>
               <a:rPr sz="10410" b="1">
                 <a:solidFill>
-                  <a:srgbClr val="0000FF"/>
+                  <a:srgbClr val="008000"/>
                 </a:solidFill>
                 <a:latin typeface="Arial"/>
               </a:rPr>
@@ -11047,7 +11047,7 @@
             <a:r>
               <a:rPr sz="10410" b="1">
                 <a:solidFill>
-                  <a:srgbClr val="0000FF"/>
+                  <a:srgbClr val="008000"/>
                 </a:solidFill>
                 <a:latin typeface="Arial"/>
               </a:rPr>
@@ -11093,7 +11093,7 @@
             <a:r>
               <a:rPr sz="10410" b="1">
                 <a:solidFill>
-                  <a:srgbClr val="0000FF"/>
+                  <a:srgbClr val="008000"/>
                 </a:solidFill>
                 <a:latin typeface="Arial"/>
               </a:rPr>
@@ -11139,7 +11139,7 @@
             <a:r>
               <a:rPr sz="10410" b="1">
                 <a:solidFill>
-                  <a:srgbClr val="0000FF"/>
+                  <a:srgbClr val="008000"/>
                 </a:solidFill>
                 <a:latin typeface="Arial"/>
               </a:rPr>
@@ -11185,7 +11185,7 @@
             <a:r>
               <a:rPr sz="10410" b="1">
                 <a:solidFill>
-                  <a:srgbClr val="0000FF"/>
+                  <a:srgbClr val="008000"/>
                 </a:solidFill>
                 <a:latin typeface="Arial"/>
               </a:rPr>
@@ -12705,7 +12705,7 @@
             <a:r>
               <a:rPr sz="10410" b="1">
                 <a:solidFill>
-                  <a:srgbClr val="0000FF"/>
+                  <a:srgbClr val="008000"/>
                 </a:solidFill>
                 <a:latin typeface="Arial"/>
               </a:rPr>
@@ -12751,7 +12751,7 @@
             <a:r>
               <a:rPr sz="10410" b="1">
                 <a:solidFill>
-                  <a:srgbClr val="0000FF"/>
+                  <a:srgbClr val="008000"/>
                 </a:solidFill>
                 <a:latin typeface="Arial"/>
               </a:rPr>
@@ -12797,7 +12797,7 @@
             <a:r>
               <a:rPr sz="10410" b="1">
                 <a:solidFill>
-                  <a:srgbClr val="0000FF"/>
+                  <a:srgbClr val="008000"/>
                 </a:solidFill>
                 <a:latin typeface="Arial"/>
               </a:rPr>

</xml_diff>